<commit_message>
Art deck at 2x detail; headless in-game frames for mockup/HUD slides
The exporter now renders the mockup, readability and HUD slides with the
real GameScreen running headless on @napi-rs/canvas. Fixes a crash when
placing with the grid overlay (overlay larger than an atlas page).

Co-Authored-By: Claude Opus 5.5 <noreply@anthropic.com>
</commit_message>
<xml_diff>
--- a/art-preview.pptx
+++ b/art-preview.pptx
@@ -516,7 +516,7 @@
           <a:p>
             <a:r>
               <a:rPr lang="en-US" dirty="0"/>
-              <a:t>Title and art direction summary.
+              <a:t>Title and art direction summary (2x detail).
 Source PNG: art-preview/slides/01-title.png (the PNGs are the source of truth; PowerPoint may smooth when zoomed).</a:t>
             </a:r>
             <a:endParaRPr lang="en-US" dirty="0"/>
@@ -605,7 +605,7 @@
           <a:p>
             <a:r>
               <a:rPr lang="en-US" dirty="0"/>
-              <a:t>Readability check: everything at actual default-zoom size (1 art px = 4 screen px).
+              <a:t>Readability: the exact 1080p frame (UI S=4, world SW=2), HUD included.
 Source PNG: art-preview/slides/10-readability.png (the PNGs are the source of truth; PowerPoint may smooth when zoomed).</a:t>
             </a:r>
             <a:endParaRPr lang="en-US" dirty="0"/>
@@ -783,7 +783,7 @@
           <a:p>
             <a:r>
               <a:rPr lang="en-US" dirty="0"/>
-              <a:t>Explosion frame strips (pixel fireball -&gt; breakup -&gt; smoke), smoke puff, scorch decals, debris, rain.
+              <a:t>Explosion frame strips (fireball -&gt; breakup -&gt; smoke), smoke puff, scorch decals, debris, rain.
 Source PNG: art-preview/slides/12-vfx-2.png (the PNGs are the source of truth; PowerPoint may smooth when zoomed).</a:t>
             </a:r>
             <a:endParaRPr lang="en-US" dirty="0"/>
@@ -872,7 +872,7 @@
           <a:p>
             <a:r>
               <a:rPr lang="en-US" dirty="0"/>
-              <a:t>HUD with drag-ghost placement at the iPhone 12 view size. Placeholder numbers.
+              <a:t>HUD with drag-ghost placement, rendered by the game at the iPhone 12 size.
 Source PNG: art-preview/slides/13-ui-placement.png (the PNGs are the source of truth; PowerPoint may smooth when zoomed).</a:t>
             </a:r>
             <a:endParaRPr lang="en-US" dirty="0"/>
@@ -961,7 +961,7 @@
           <a:p>
             <a:r>
               <a:rPr lang="en-US" dirty="0"/>
-              <a:t>Tower info panel and icon set. Placeholder numbers.
+              <a:t>Tower info panel and icon set, rendered by the game.
 Source PNG: art-preview/slides/14-ui-info.png (the PNGs are the source of truth; PowerPoint may smooth when zoomed).</a:t>
             </a:r>
             <a:endParaRPr lang="en-US" dirty="0"/>
@@ -1584,7 +1584,7 @@
           <a:p>
             <a:r>
               <a:rPr lang="en-US" dirty="0"/>
-              <a:t>Shield Droid: rolls on twin treads, deploys into a slow walker with shield up. Strike Fighter: air unit.
+              <a:t>Shield Droid: tread sled, deploys into a slow walker with shield up. Strike Fighter: air unit.
 Source PNG: art-preview/slides/07-enemies-2.png (the PNGs are the source of truth; PowerPoint may smooth when zoomed).</a:t>
             </a:r>
             <a:endParaRPr lang="en-US" dirty="0"/>
@@ -1673,7 +1673,7 @@
           <a:p>
             <a:r>
               <a:rPr lang="en-US" dirty="0"/>
-              <a:t>Ground variants, walkway, pad, 4-frame water, platform edge with stilts, bridge truss, props, autotile sample.
+              <a:t>Ground variants, walkway, pad, 8-frame water, platform edge with stilts, bridge truss, props, autotile sample.
 Source PNG: art-preview/slides/08-kamino-tiles.png (the PNGs are the source of truth; PowerPoint may smooth when zoomed).</a:t>
             </a:r>
             <a:endParaRPr lang="en-US" dirty="0"/>
@@ -1762,7 +1762,7 @@
           <a:p>
             <a:r>
               <a:rPr lang="en-US" dirty="0"/>
-              <a:t>One screen of the Kamino mockup map with towers, enemies, air units and effects.
+              <a:t>One screen of Kamino 1 rendered by the game (HUD hidden).
 Source PNG: art-preview/slides/09-kamino-mockup.png (the PNGs are the source of truth; PowerPoint may smooth when zoomed).</a:t>
             </a:r>
             <a:endParaRPr lang="en-US" dirty="0"/>

</xml_diff>